<commit_message>
añadido workflow a PAT
</commit_message>
<xml_diff>
--- a/docs/diapositivas/presentacion_modulo_v2.pptx
+++ b/docs/diapositivas/presentacion_modulo_v2.pptx
@@ -117,6 +117,11 @@
       </a:defRPr>
     </a:lvl9pPr>
   </p:defaultTextStyle>
+  <p:extLst>
+    <p:ext uri="{EFAFB233-063F-42B5-8137-9DF3F51BA10A}">
+      <p15:sldGuideLst xmlns:p15="http://schemas.microsoft.com/office/powerpoint/2012/main"/>
+    </p:ext>
+  </p:extLst>
 </p:presentation>
 </file>
 
@@ -22356,10 +22361,10 @@
       </p:sp>
       <p:grpSp>
         <p:nvGrpSpPr>
-          <p:cNvPr id="2" name="Grupo 1">
+          <p:cNvPr id="5" name="Grupo 4">
             <a:extLst>
               <a:ext uri="{FF2B5EF4-FFF2-40B4-BE49-F238E27FC236}">
-                <a16:creationId xmlns:a16="http://schemas.microsoft.com/office/drawing/2014/main" id="{CC4ACAD6-53C9-E769-7BF0-2ADB1CE1DF57}"/>
+                <a16:creationId xmlns:a16="http://schemas.microsoft.com/office/drawing/2014/main" id="{7B72E38F-7467-402F-A594-55908D7C5622}"/>
               </a:ext>
             </a:extLst>
           </p:cNvPr>
@@ -22368,22 +22373,28 @@
         </p:nvGrpSpPr>
         <p:grpSpPr>
           <a:xfrm>
-            <a:off x="1478280" y="1777266"/>
-            <a:ext cx="8887680" cy="712800"/>
-            <a:chOff x="777240" y="1481400"/>
-            <a:chExt cx="8887680" cy="712800"/>
+            <a:off x="1545177" y="1758261"/>
+            <a:ext cx="9101045" cy="732975"/>
+            <a:chOff x="1048800" y="1758907"/>
+            <a:chExt cx="9101045" cy="732975"/>
           </a:xfrm>
         </p:grpSpPr>
         <p:sp>
           <p:nvSpPr>
-            <p:cNvPr id="238" name="Shape 4"/>
+            <p:cNvPr id="4" name="Shape 14">
+              <a:extLst>
+                <a:ext uri="{FF2B5EF4-FFF2-40B4-BE49-F238E27FC236}">
+                  <a16:creationId xmlns:a16="http://schemas.microsoft.com/office/drawing/2014/main" id="{9CAD67D2-99F9-6CD5-21DA-472DFDA65B80}"/>
+                </a:ext>
+              </a:extLst>
+            </p:cNvPr>
             <p:cNvSpPr/>
             <p:nvPr/>
           </p:nvSpPr>
           <p:spPr>
             <a:xfrm>
-              <a:off x="777240" y="1481400"/>
-              <a:ext cx="1508400" cy="712800"/>
+              <a:off x="5673900" y="1768087"/>
+              <a:ext cx="2156895" cy="712800"/>
             </a:xfrm>
             <a:prstGeom prst="roundRect">
               <a:avLst>
@@ -22431,14 +22442,69 @@
         </p:sp>
         <p:sp>
           <p:nvSpPr>
+            <p:cNvPr id="238" name="Shape 4"/>
+            <p:cNvSpPr/>
+            <p:nvPr/>
+          </p:nvSpPr>
+          <p:spPr>
+            <a:xfrm>
+              <a:off x="1048800" y="1768087"/>
+              <a:ext cx="2156895" cy="712800"/>
+            </a:xfrm>
+            <a:prstGeom prst="roundRect">
+              <a:avLst>
+                <a:gd name="adj" fmla="val 10256"/>
+              </a:avLst>
+            </a:prstGeom>
+            <a:solidFill>
+              <a:srgbClr val="E0F2F1"/>
+            </a:solidFill>
+            <a:ln w="15240">
+              <a:solidFill>
+                <a:srgbClr val="00897B"/>
+              </a:solidFill>
+              <a:round/>
+            </a:ln>
+          </p:spPr>
+          <p:style>
+            <a:lnRef idx="0">
+              <a:scrgbClr r="0" g="0" b="0"/>
+            </a:lnRef>
+            <a:fillRef idx="0">
+              <a:scrgbClr r="0" g="0" b="0"/>
+            </a:fillRef>
+            <a:effectRef idx="0">
+              <a:scrgbClr r="0" g="0" b="0"/>
+            </a:effectRef>
+            <a:fontRef idx="minor"/>
+          </p:style>
+          <p:txBody>
+            <a:bodyPr lIns="90000" tIns="45000" rIns="90000" bIns="45000" anchor="t">
+              <a:noAutofit/>
+            </a:bodyPr>
+            <a:lstStyle/>
+            <a:p>
+              <a:endParaRPr lang="en-US" sz="1800" b="0" u="none" strike="noStrike">
+                <a:solidFill>
+                  <a:srgbClr val="000000"/>
+                </a:solidFill>
+                <a:effectLst/>
+                <a:uFillTx/>
+                <a:latin typeface="Arial"/>
+              </a:endParaRPr>
+            </a:p>
+          </p:txBody>
+        </p:sp>
+        <p:sp>
+          <p:nvSpPr>
             <p:cNvPr id="239" name="Text 5"/>
             <p:cNvSpPr/>
             <p:nvPr/>
           </p:nvSpPr>
           <p:spPr>
             <a:xfrm>
-              <a:off x="822960" y="1554480"/>
-              <a:ext cx="1416960" cy="548280"/>
+              <a:off x="1629932" y="1858179"/>
+              <a:ext cx="994630" cy="548280"/>
             </a:xfrm>
             <a:prstGeom prst="rect">
               <a:avLst/>
@@ -22505,6 +22571,16 @@
                 </a:tabLst>
               </a:pPr>
               <a:r>
+                <a:rPr lang="en-US" sz="1700" b="1" dirty="0">
+                  <a:solidFill>
+                    <a:srgbClr val="004D40"/>
+                  </a:solidFill>
+                  <a:latin typeface="Arial"/>
+                  <a:ea typeface="Arial"/>
+                </a:rPr>
+                <a:t>3</a:t>
+              </a:r>
+              <a:r>
                 <a:rPr lang="en-US" sz="1700" b="1" u="none" strike="noStrike" dirty="0">
                   <a:solidFill>
                     <a:srgbClr val="004D40"/>
@@ -22514,7 +22590,7 @@
                   <a:latin typeface="Arial"/>
                   <a:ea typeface="Arial"/>
                 </a:rPr>
-                <a:t>20 %</a:t>
+                <a:t>0 %</a:t>
               </a:r>
               <a:endParaRPr lang="en-US" sz="1700" b="0" u="none" strike="noStrike" dirty="0">
                 <a:solidFill>
@@ -22535,8 +22611,8 @@
           </p:nvSpPr>
           <p:spPr>
             <a:xfrm>
-              <a:off x="2541960" y="1481400"/>
-              <a:ext cx="1508400" cy="712800"/>
+              <a:off x="3367850" y="1779082"/>
+              <a:ext cx="2156895" cy="712800"/>
             </a:xfrm>
             <a:prstGeom prst="roundRect">
               <a:avLst>
@@ -22590,8 +22666,8 @@
           </p:nvSpPr>
           <p:spPr>
             <a:xfrm>
-              <a:off x="2587680" y="1554480"/>
-              <a:ext cx="1416960" cy="548280"/>
+              <a:off x="4044882" y="1858179"/>
+              <a:ext cx="802830" cy="548280"/>
             </a:xfrm>
             <a:prstGeom prst="rect">
               <a:avLst/>
@@ -22667,217 +22743,9 @@
                   <a:latin typeface="Arial"/>
                   <a:ea typeface="Arial"/>
                 </a:rPr>
-                <a:t>20 %</a:t>
+                <a:t>30 %</a:t>
               </a:r>
               <a:endParaRPr lang="en-US" sz="1700" b="0" u="none" strike="noStrike" dirty="0">
-                <a:solidFill>
-                  <a:srgbClr val="000000"/>
-                </a:solidFill>
-                <a:effectLst/>
-                <a:uFillTx/>
-                <a:latin typeface="Arial"/>
-              </a:endParaRPr>
-            </a:p>
-          </p:txBody>
-        </p:sp>
-        <p:sp>
-          <p:nvSpPr>
-            <p:cNvPr id="242" name="Shape 8"/>
-            <p:cNvSpPr/>
-            <p:nvPr/>
-          </p:nvSpPr>
-          <p:spPr>
-            <a:xfrm>
-              <a:off x="4306680" y="1481400"/>
-              <a:ext cx="1508400" cy="712800"/>
-            </a:xfrm>
-            <a:prstGeom prst="roundRect">
-              <a:avLst>
-                <a:gd name="adj" fmla="val 10256"/>
-              </a:avLst>
-            </a:prstGeom>
-            <a:solidFill>
-              <a:srgbClr val="E0F2F1"/>
-            </a:solidFill>
-            <a:ln w="15240">
-              <a:solidFill>
-                <a:srgbClr val="00897B"/>
-              </a:solidFill>
-              <a:round/>
-            </a:ln>
-          </p:spPr>
-          <p:style>
-            <a:lnRef idx="0">
-              <a:scrgbClr r="0" g="0" b="0"/>
-            </a:lnRef>
-            <a:fillRef idx="0">
-              <a:scrgbClr r="0" g="0" b="0"/>
-            </a:fillRef>
-            <a:effectRef idx="0">
-              <a:scrgbClr r="0" g="0" b="0"/>
-            </a:effectRef>
-            <a:fontRef idx="minor"/>
-          </p:style>
-          <p:txBody>
-            <a:bodyPr lIns="90000" tIns="45000" rIns="90000" bIns="45000" anchor="t">
-              <a:noAutofit/>
-            </a:bodyPr>
-            <a:lstStyle/>
-            <a:p>
-              <a:endParaRPr lang="en-US" sz="1800" b="0" u="none" strike="noStrike">
-                <a:solidFill>
-                  <a:srgbClr val="000000"/>
-                </a:solidFill>
-                <a:effectLst/>
-                <a:uFillTx/>
-                <a:latin typeface="Arial"/>
-              </a:endParaRPr>
-            </a:p>
-          </p:txBody>
-        </p:sp>
-        <p:sp>
-          <p:nvSpPr>
-            <p:cNvPr id="243" name="Text 9"/>
-            <p:cNvSpPr/>
-            <p:nvPr/>
-          </p:nvSpPr>
-          <p:spPr>
-            <a:xfrm>
-              <a:off x="4352400" y="1554480"/>
-              <a:ext cx="1416960" cy="548280"/>
-            </a:xfrm>
-            <a:prstGeom prst="rect">
-              <a:avLst/>
-            </a:prstGeom>
-            <a:noFill/>
-            <a:ln w="0">
-              <a:noFill/>
-            </a:ln>
-          </p:spPr>
-          <p:style>
-            <a:lnRef idx="0">
-              <a:scrgbClr r="0" g="0" b="0"/>
-            </a:lnRef>
-            <a:fillRef idx="0">
-              <a:scrgbClr r="0" g="0" b="0"/>
-            </a:fillRef>
-            <a:effectRef idx="0">
-              <a:scrgbClr r="0" g="0" b="0"/>
-            </a:effectRef>
-            <a:fontRef idx="minor"/>
-          </p:style>
-          <p:txBody>
-            <a:bodyPr lIns="0" tIns="0" rIns="0" bIns="0" anchor="ctr">
-              <a:normAutofit/>
-            </a:bodyPr>
-            <a:lstStyle/>
-            <a:p>
-              <a:pPr algn="ctr" defTabSz="914400">
-                <a:lnSpc>
-                  <a:spcPct val="100000"/>
-                </a:lnSpc>
-                <a:tabLst>
-                  <a:tab pos="0" algn="l"/>
-                </a:tabLst>
-              </a:pPr>
-              <a:r>
-                <a:rPr lang="en-US" sz="1700" b="1" u="none" strike="noStrike">
-                  <a:solidFill>
-                    <a:srgbClr val="004D40"/>
-                  </a:solidFill>
-                  <a:effectLst/>
-                  <a:uFillTx/>
-                  <a:latin typeface="Arial"/>
-                  <a:ea typeface="Arial"/>
-                </a:rPr>
-                <a:t>RA3</a:t>
-              </a:r>
-              <a:endParaRPr lang="en-US" sz="1700" b="0" u="none" strike="noStrike">
-                <a:solidFill>
-                  <a:srgbClr val="000000"/>
-                </a:solidFill>
-                <a:effectLst/>
-                <a:uFillTx/>
-                <a:latin typeface="Arial"/>
-              </a:endParaRPr>
-            </a:p>
-            <a:p>
-              <a:pPr algn="ctr" defTabSz="914400">
-                <a:lnSpc>
-                  <a:spcPct val="100000"/>
-                </a:lnSpc>
-                <a:tabLst>
-                  <a:tab pos="0" algn="l"/>
-                </a:tabLst>
-              </a:pPr>
-              <a:r>
-                <a:rPr lang="en-US" sz="1700" b="1" u="none" strike="noStrike">
-                  <a:solidFill>
-                    <a:srgbClr val="004D40"/>
-                  </a:solidFill>
-                  <a:effectLst/>
-                  <a:uFillTx/>
-                  <a:latin typeface="Arial"/>
-                  <a:ea typeface="Arial"/>
-                </a:rPr>
-                <a:t>20 %</a:t>
-              </a:r>
-              <a:endParaRPr lang="en-US" sz="1700" b="0" u="none" strike="noStrike">
-                <a:solidFill>
-                  <a:srgbClr val="000000"/>
-                </a:solidFill>
-                <a:effectLst/>
-                <a:uFillTx/>
-                <a:latin typeface="Arial"/>
-              </a:endParaRPr>
-            </a:p>
-          </p:txBody>
-        </p:sp>
-        <p:sp>
-          <p:nvSpPr>
-            <p:cNvPr id="244" name="Shape 10"/>
-            <p:cNvSpPr/>
-            <p:nvPr/>
-          </p:nvSpPr>
-          <p:spPr>
-            <a:xfrm>
-              <a:off x="6071760" y="1481400"/>
-              <a:ext cx="868320" cy="712800"/>
-            </a:xfrm>
-            <a:prstGeom prst="roundRect">
-              <a:avLst>
-                <a:gd name="adj" fmla="val 10256"/>
-              </a:avLst>
-            </a:prstGeom>
-            <a:solidFill>
-              <a:srgbClr val="E0F7FA"/>
-            </a:solidFill>
-            <a:ln w="15240">
-              <a:solidFill>
-                <a:srgbClr val="00ACC1"/>
-              </a:solidFill>
-              <a:round/>
-            </a:ln>
-          </p:spPr>
-          <p:style>
-            <a:lnRef idx="0">
-              <a:scrgbClr r="0" g="0" b="0"/>
-            </a:lnRef>
-            <a:fillRef idx="0">
-              <a:scrgbClr r="0" g="0" b="0"/>
-            </a:fillRef>
-            <a:effectRef idx="0">
-              <a:scrgbClr r="0" g="0" b="0"/>
-            </a:effectRef>
-            <a:fontRef idx="minor"/>
-          </p:style>
-          <p:txBody>
-            <a:bodyPr lIns="90000" tIns="45000" rIns="90000" bIns="45000" anchor="t">
-              <a:noAutofit/>
-            </a:bodyPr>
-            <a:lstStyle/>
-            <a:p>
-              <a:endParaRPr lang="en-US" sz="1800" b="0" u="none" strike="noStrike">
                 <a:solidFill>
                   <a:srgbClr val="000000"/>
                 </a:solidFill>
@@ -22896,7 +22764,7 @@
           </p:nvSpPr>
           <p:spPr>
             <a:xfrm>
-              <a:off x="6117480" y="1554480"/>
+              <a:off x="6363907" y="1841167"/>
               <a:ext cx="776880" cy="548280"/>
             </a:xfrm>
             <a:prstGeom prst="rect">
@@ -22925,33 +22793,24 @@
             </a:bodyPr>
             <a:lstStyle/>
             <a:p>
-              <a:pPr algn="ctr" defTabSz="914400">
-                <a:lnSpc>
-                  <a:spcPct val="100000"/>
-                </a:lnSpc>
+              <a:pPr algn="ctr">
                 <a:tabLst>
                   <a:tab pos="0" algn="l"/>
                 </a:tabLst>
               </a:pPr>
               <a:r>
-                <a:rPr lang="en-US" sz="1700" b="1" u="none" strike="noStrike">
+                <a:rPr lang="en-US" sz="1700" b="1" dirty="0">
                   <a:solidFill>
                     <a:srgbClr val="004D40"/>
                   </a:solidFill>
-                  <a:effectLst/>
-                  <a:uFillTx/>
-                  <a:latin typeface="Arial"/>
                   <a:ea typeface="Arial"/>
                 </a:rPr>
-                <a:t>RA4</a:t>
+                <a:t>RA3</a:t>
               </a:r>
-              <a:endParaRPr lang="en-US" sz="1700" b="0" u="none" strike="noStrike">
+              <a:endParaRPr lang="en-US" sz="1700" dirty="0">
                 <a:solidFill>
                   <a:srgbClr val="000000"/>
                 </a:solidFill>
-                <a:effectLst/>
-                <a:uFillTx/>
-                <a:latin typeface="Arial"/>
               </a:endParaRPr>
             </a:p>
             <a:p>
@@ -22964,7 +22823,17 @@
                 </a:tabLst>
               </a:pPr>
               <a:r>
-                <a:rPr lang="en-US" sz="1700" b="1" u="none" strike="noStrike">
+                <a:rPr lang="en-US" sz="1700" b="1" dirty="0">
+                  <a:solidFill>
+                    <a:srgbClr val="004D40"/>
+                  </a:solidFill>
+                  <a:latin typeface="Arial"/>
+                  <a:ea typeface="Arial"/>
+                </a:rPr>
+                <a:t>25</a:t>
+              </a:r>
+              <a:r>
+                <a:rPr lang="en-US" sz="1700" b="1" u="none" strike="noStrike" dirty="0">
                   <a:solidFill>
                     <a:srgbClr val="004D40"/>
                   </a:solidFill>
@@ -22973,9 +22842,9 @@
                   <a:latin typeface="Arial"/>
                   <a:ea typeface="Arial"/>
                 </a:rPr>
-                <a:t>10 %</a:t>
+                <a:t> %</a:t>
               </a:r>
-              <a:endParaRPr lang="en-US" sz="1700" b="0" u="none" strike="noStrike">
+              <a:endParaRPr lang="en-US" sz="1700" b="0" u="none" strike="noStrike" dirty="0">
                 <a:solidFill>
                   <a:srgbClr val="000000"/>
                 </a:solidFill>
@@ -22988,14 +22857,14 @@
         </p:sp>
         <p:sp>
           <p:nvSpPr>
-            <p:cNvPr id="246" name="Shape 12"/>
+            <p:cNvPr id="248" name="Shape 14"/>
             <p:cNvSpPr/>
             <p:nvPr/>
           </p:nvSpPr>
           <p:spPr>
             <a:xfrm>
-              <a:off x="7113960" y="1481400"/>
-              <a:ext cx="868320" cy="712800"/>
+              <a:off x="7992950" y="1758907"/>
+              <a:ext cx="2156895" cy="712800"/>
             </a:xfrm>
             <a:prstGeom prst="roundRect">
               <a:avLst>
@@ -23003,11 +22872,11 @@
               </a:avLst>
             </a:prstGeom>
             <a:solidFill>
-              <a:srgbClr val="E0F7FA"/>
+              <a:srgbClr val="E0F2F1"/>
             </a:solidFill>
             <a:ln w="15240">
               <a:solidFill>
-                <a:srgbClr val="00ACC1"/>
+                <a:srgbClr val="00897B"/>
               </a:solidFill>
               <a:round/>
             </a:ln>
@@ -23043,14 +22912,14 @@
         </p:sp>
         <p:sp>
           <p:nvSpPr>
-            <p:cNvPr id="247" name="Text 13"/>
+            <p:cNvPr id="249" name="Text 15"/>
             <p:cNvSpPr/>
             <p:nvPr/>
           </p:nvSpPr>
           <p:spPr>
             <a:xfrm>
-              <a:off x="7159680" y="1554480"/>
-              <a:ext cx="776880" cy="548280"/>
+              <a:off x="8147050" y="1852162"/>
+              <a:ext cx="1835150" cy="548280"/>
             </a:xfrm>
             <a:prstGeom prst="rect">
               <a:avLst/>
@@ -23096,7 +22965,7 @@
                   <a:latin typeface="Arial"/>
                   <a:ea typeface="Arial"/>
                 </a:rPr>
-                <a:t>RA5</a:t>
+                <a:t>RA6</a:t>
               </a:r>
               <a:endParaRPr lang="en-US" sz="1700" b="0" u="none" strike="noStrike" dirty="0">
                 <a:solidFill>
@@ -23126,162 +22995,9 @@
                   <a:latin typeface="Arial"/>
                   <a:ea typeface="Arial"/>
                 </a:rPr>
-                <a:t>10 %</a:t>
+                <a:t>25 %</a:t>
               </a:r>
               <a:endParaRPr lang="en-US" sz="1700" b="0" u="none" strike="noStrike" dirty="0">
-                <a:solidFill>
-                  <a:srgbClr val="000000"/>
-                </a:solidFill>
-                <a:effectLst/>
-                <a:uFillTx/>
-                <a:latin typeface="Arial"/>
-              </a:endParaRPr>
-            </a:p>
-          </p:txBody>
-        </p:sp>
-        <p:sp>
-          <p:nvSpPr>
-            <p:cNvPr id="248" name="Shape 14"/>
-            <p:cNvSpPr/>
-            <p:nvPr/>
-          </p:nvSpPr>
-          <p:spPr>
-            <a:xfrm>
-              <a:off x="8156520" y="1481400"/>
-              <a:ext cx="1508400" cy="712800"/>
-            </a:xfrm>
-            <a:prstGeom prst="roundRect">
-              <a:avLst>
-                <a:gd name="adj" fmla="val 10256"/>
-              </a:avLst>
-            </a:prstGeom>
-            <a:solidFill>
-              <a:srgbClr val="E0F2F1"/>
-            </a:solidFill>
-            <a:ln w="15240">
-              <a:solidFill>
-                <a:srgbClr val="00897B"/>
-              </a:solidFill>
-              <a:round/>
-            </a:ln>
-          </p:spPr>
-          <p:style>
-            <a:lnRef idx="0">
-              <a:scrgbClr r="0" g="0" b="0"/>
-            </a:lnRef>
-            <a:fillRef idx="0">
-              <a:scrgbClr r="0" g="0" b="0"/>
-            </a:fillRef>
-            <a:effectRef idx="0">
-              <a:scrgbClr r="0" g="0" b="0"/>
-            </a:effectRef>
-            <a:fontRef idx="minor"/>
-          </p:style>
-          <p:txBody>
-            <a:bodyPr lIns="90000" tIns="45000" rIns="90000" bIns="45000" anchor="t">
-              <a:noAutofit/>
-            </a:bodyPr>
-            <a:lstStyle/>
-            <a:p>
-              <a:endParaRPr lang="en-US" sz="1800" b="0" u="none" strike="noStrike">
-                <a:solidFill>
-                  <a:srgbClr val="000000"/>
-                </a:solidFill>
-                <a:effectLst/>
-                <a:uFillTx/>
-                <a:latin typeface="Arial"/>
-              </a:endParaRPr>
-            </a:p>
-          </p:txBody>
-        </p:sp>
-        <p:sp>
-          <p:nvSpPr>
-            <p:cNvPr id="249" name="Text 15"/>
-            <p:cNvSpPr/>
-            <p:nvPr/>
-          </p:nvSpPr>
-          <p:spPr>
-            <a:xfrm>
-              <a:off x="8202240" y="1554480"/>
-              <a:ext cx="1416960" cy="548280"/>
-            </a:xfrm>
-            <a:prstGeom prst="rect">
-              <a:avLst/>
-            </a:prstGeom>
-            <a:noFill/>
-            <a:ln w="0">
-              <a:noFill/>
-            </a:ln>
-          </p:spPr>
-          <p:style>
-            <a:lnRef idx="0">
-              <a:scrgbClr r="0" g="0" b="0"/>
-            </a:lnRef>
-            <a:fillRef idx="0">
-              <a:scrgbClr r="0" g="0" b="0"/>
-            </a:fillRef>
-            <a:effectRef idx="0">
-              <a:scrgbClr r="0" g="0" b="0"/>
-            </a:effectRef>
-            <a:fontRef idx="minor"/>
-          </p:style>
-          <p:txBody>
-            <a:bodyPr lIns="0" tIns="0" rIns="0" bIns="0" anchor="ctr">
-              <a:normAutofit/>
-            </a:bodyPr>
-            <a:lstStyle/>
-            <a:p>
-              <a:pPr algn="ctr" defTabSz="914400">
-                <a:lnSpc>
-                  <a:spcPct val="100000"/>
-                </a:lnSpc>
-                <a:tabLst>
-                  <a:tab pos="0" algn="l"/>
-                </a:tabLst>
-              </a:pPr>
-              <a:r>
-                <a:rPr lang="en-US" sz="1700" b="1" u="none" strike="noStrike">
-                  <a:solidFill>
-                    <a:srgbClr val="004D40"/>
-                  </a:solidFill>
-                  <a:effectLst/>
-                  <a:uFillTx/>
-                  <a:latin typeface="Arial"/>
-                  <a:ea typeface="Arial"/>
-                </a:rPr>
-                <a:t>RA6</a:t>
-              </a:r>
-              <a:endParaRPr lang="en-US" sz="1700" b="0" u="none" strike="noStrike">
-                <a:solidFill>
-                  <a:srgbClr val="000000"/>
-                </a:solidFill>
-                <a:effectLst/>
-                <a:uFillTx/>
-                <a:latin typeface="Arial"/>
-              </a:endParaRPr>
-            </a:p>
-            <a:p>
-              <a:pPr algn="ctr" defTabSz="914400">
-                <a:lnSpc>
-                  <a:spcPct val="100000"/>
-                </a:lnSpc>
-                <a:tabLst>
-                  <a:tab pos="0" algn="l"/>
-                </a:tabLst>
-              </a:pPr>
-              <a:r>
-                <a:rPr lang="en-US" sz="1700" b="1" u="none" strike="noStrike">
-                  <a:solidFill>
-                    <a:srgbClr val="004D40"/>
-                  </a:solidFill>
-                  <a:effectLst/>
-                  <a:uFillTx/>
-                  <a:latin typeface="Arial"/>
-                  <a:ea typeface="Arial"/>
-                </a:rPr>
-                <a:t>20 %</a:t>
-              </a:r>
-              <a:endParaRPr lang="en-US" sz="1700" b="0" u="none" strike="noStrike">
                 <a:solidFill>
                   <a:srgbClr val="000000"/>
                 </a:solidFill>

</xml_diff>